<commit_message>
lectures: normalize cover course number to ECE 30861 / CSCI 45000
Replace the stale single-paragraph cover form "ECE 30861/46100: Software
Engineering" with the reference deck's (1-3) Title 2 textbox — identical
run/paragraph structure, formatting, and frame geometry — in 1-5, 1-6,
1-7, 1-8, 1-9, 2-1, 2-2. In 1-2, which carried both forms on slide 1,
delete the stale shape (the correct one was already present). Update the
cached docProps/app.xml title entries to match. In 1-1, normalize the
seven slide-layout footer placeholders still reading "ECE 461 - Fall'21"
to byte-match the reference deck's layouts. Repo-wide occurrences of
"ECE 461"/"46100" in deck XML: now zero. All 9 decks pass
tools/pptx_validate.py (0 OPC, 0 schema).

Co-Authored-By: Claude Opus 5 <noreply@anthropic.com>
</commit_message>
<xml_diff>
--- a/course/lectures/act-1-foundations/05-specification/slides/1-5-Specification.pptx
+++ b/course/lectures/act-1-foundations/05-specification/slides/1-5-Specification.pptx
@@ -7198,36 +7198,70 @@
           <p:cNvPr id="3" name="Title 2">
             <a:extLst>
               <a:ext uri="{FF2B5EF4-FFF2-40B4-BE49-F238E27FC236}">
-                <a16:creationId xmlns:a16="http://schemas.microsoft.com/office/drawing/2014/main" id="{089D1F61-B74F-FD46-9676-D29849AD2577}"/>
+                <a16:creationId xmlns:a16="http://schemas.microsoft.com/office/drawing/2014/main" id="{DD7291C3-5AE9-477A-3F39-34A06A62D99C}"/>
               </a:ext>
             </a:extLst>
           </p:cNvPr>
-          <p:cNvSpPr>
-            <a:spLocks noGrp="1"/>
+          <p:cNvSpPr txBox="1">
+            <a:spLocks/>
           </p:cNvSpPr>
-          <p:nvPr>
-            <p:ph type="ctrTitle"/>
-          </p:nvPr>
-        </p:nvSpPr>
-        <p:spPr>
-          <a:xfrm>
-            <a:off x="439339" y="565150"/>
-            <a:ext cx="8265319" cy="874712"/>
-          </a:xfrm>
-        </p:spPr>
-        <p:txBody>
-          <a:bodyPr>
+          <p:nvPr/>
+        </p:nvSpPr>
+        <p:spPr bwMode="black">
+          <a:xfrm>
+            <a:off x="439339" y="565149"/>
+            <a:ext cx="8265319" cy="1195411"/>
+          </a:xfrm>
+          <a:prstGeom prst="rect">
+            <a:avLst/>
+          </a:prstGeom>
+          <a:solidFill>
+            <a:srgbClr val="FFFFFF"/>
+          </a:solidFill>
+          <a:ln w="31750" cap="sq">
+            <a:noFill/>
+            <a:miter lim="800000"/>
+          </a:ln>
+        </p:spPr>
+        <p:txBody>
+          <a:bodyPr vert="horz" lIns="182880" tIns="182880" rIns="182880" bIns="182880" rtlCol="0" anchor="ctr">
             <a:normAutofit/>
           </a:bodyPr>
-          <a:lstStyle/>
-          <a:p>
-            <a:pPr>
-              <a:defRPr b="0"/>
-            </a:pPr>
-            <a:r>
-              <a:rPr lang="en-US" sz="2000" b="0" i="1" dirty="0"/>
-              <a:t>ECE 30861/46100: Software Engineering</a:t>
-            </a:r>
+          <a:lstStyle>
+            <a:lvl1pPr algn="ctr" defTabSz="914400" rtl="0" eaLnBrk="1" latinLnBrk="0" hangingPunct="1">
+              <a:lnSpc>
+                <a:spcPct val="90000"/>
+              </a:lnSpc>
+              <a:spcBef>
+                <a:spcPct val="0"/>
+              </a:spcBef>
+              <a:buNone/>
+              <a:defRPr sz="3600" kern="1200" cap="none" spc="200" baseline="0">
+                <a:solidFill>
+                  <a:srgbClr val="000000"/>
+                </a:solidFill>
+                <a:latin typeface="Calibri" panose="020F0502020204030204" pitchFamily="34" charset="0"/>
+                <a:ea typeface="+mj-ea"/>
+                <a:cs typeface="Calibri" panose="020F0502020204030204" pitchFamily="34" charset="0"/>
+              </a:defRPr>
+            </a:lvl1pPr>
+          </a:lstStyle>
+          <a:p>
+            <a:r>
+              <a:rPr lang="en-US" sz="2000" i="1" dirty="0"/>
+              <a:t>Software Engineering</a:t>
+            </a:r>
+            <a:br>
+              <a:rPr lang="en-US" sz="2000" i="1" dirty="0"/>
+            </a:br>
+            <a:br>
+              <a:rPr lang="en-US" sz="2000" i="1" dirty="0"/>
+            </a:br>
+            <a:r>
+              <a:rPr lang="en-US" sz="1600" i="1" dirty="0"/>
+              <a:t>ECE 30861 / CSCI 45000</a:t>
+            </a:r>
+            <a:endParaRPr lang="en-US" sz="2000" i="1" dirty="0"/>
           </a:p>
         </p:txBody>
       </p:sp>

</xml_diff>